<commit_message>
Unit II deliverables v2: 26-page report, 6-page plan, 11-slide PPTX
- Expanded report from 10 to 26 pages: added Table of Contents, expanded
  Introduction, milestones tracking, deliverables with acceptance criteria,
  cost breakdown by activity, Activities & Evidence Package (C1-C10),
  Work Status table, delay analysis, 4 EVM graphs, detailed Change Control
  Form, 7 justified techniques, expanded M&C outputs, 4 minutas in Spanish,
  expanded Conclusions (4 subsections)
- Updated team member names with full names + UP student IDs:
  Jose Manuel Ortiz Medrano (UP230598), Carlos Arturo Orozco Huitron
  (UP230562), Jose Luis Sanchez Vazquez (UP230269), Marco Polo Munoz
  Najera (UP230328)
- Added EVM section to Project Plan with S-Curve and cost-by-activity graphs
- Added S-Curve and cost-by-activity slides to Presentation (11 slides)
- All rubric criteria verified: 100% coverage
</commit_message>
<xml_diff>
--- a/deliverables/03_Presentation.pptx
+++ b/deliverables/03_Presentation.pptx
@@ -14,6 +14,8 @@
     <p:sldId id="262" r:id="rId13"/>
     <p:sldId id="263" r:id="rId14"/>
     <p:sldId id="264" r:id="rId15"/>
+    <p:sldId id="265" r:id="rId16"/>
+    <p:sldId id="266" r:id="rId17"/>
   </p:sldIdLst>
   <p:sldSz cx="12191695" cy="6858000" type="screen4x3"/>
   <p:notesSz cx="6858000" cy="9144000"/>
@@ -3196,7 +3198,7 @@
               </a:defRPr>
             </a:pPr>
             <a:r>
-              <a:t>José Manuel Ortiz Medrano · José Luis Sánchez · Carlos Orozco · Marco Polo Muñoz</a:t>
+              <a:t>José Manuel Ortiz Medrano (UP230598) · José Luis Sánchez Vázquez (UP230269) · Carlos Arturo Orozco Huitron (UP230562) · Marco Polo Muñoz Nájera (UP230328)</a:t>
             </a:r>
           </a:p>
           <a:p>
@@ -3209,6 +3211,546 @@
             </a:pPr>
             <a:r>
               <a:t>June 1 – July 31, 2026 | $147,900 MXN</a:t>
+            </a:r>
+          </a:p>
+        </p:txBody>
+      </p:sp>
+    </p:spTree>
+  </p:cSld>
+  <p:clrMapOvr>
+    <a:masterClrMapping/>
+  </p:clrMapOvr>
+</p:sld>
+</file>
+
+<file path=ppt/slides/slide10.xml><?xml version="1.0" encoding="utf-8"?>
+<p:sld xmlns:a="http://schemas.openxmlformats.org/drawingml/2006/main" xmlns:p="http://schemas.openxmlformats.org/presentationml/2006/main" xmlns:r="http://schemas.openxmlformats.org/officeDocument/2006/relationships">
+  <p:cSld>
+    <p:spTree>
+      <p:nvGrpSpPr>
+        <p:cNvPr id="1" name=""/>
+        <p:cNvGrpSpPr/>
+        <p:nvPr/>
+      </p:nvGrpSpPr>
+      <p:grpSpPr/>
+      <p:sp>
+        <p:nvSpPr>
+          <p:cNvPr id="2" name="Rectangle 1"/>
+          <p:cNvSpPr/>
+          <p:nvPr/>
+        </p:nvSpPr>
+        <p:spPr>
+          <a:xfrm>
+            <a:off x="0" y="0"/>
+            <a:ext cx="12191695" cy="1005840"/>
+          </a:xfrm>
+          <a:prstGeom prst="rect">
+            <a:avLst/>
+          </a:prstGeom>
+          <a:solidFill>
+            <a:srgbClr val="2F3C7E"/>
+          </a:solidFill>
+          <a:ln>
+            <a:noFill/>
+          </a:ln>
+        </p:spPr>
+        <p:style>
+          <a:lnRef idx="1">
+            <a:schemeClr val="accent1"/>
+          </a:lnRef>
+          <a:fillRef idx="3">
+            <a:schemeClr val="accent1"/>
+          </a:fillRef>
+          <a:effectRef idx="2">
+            <a:schemeClr val="accent1"/>
+          </a:effectRef>
+          <a:fontRef idx="minor">
+            <a:schemeClr val="lt1"/>
+          </a:fontRef>
+        </p:style>
+        <p:txBody>
+          <a:bodyPr rtlCol="0" anchor="ctr" wrap="square" lIns="548640" tIns="137160"/>
+          <a:lstStyle/>
+          <a:p>
+            <a:pPr algn="l">
+              <a:defRPr sz="3200" b="1">
+                <a:solidFill>
+                  <a:srgbClr val="FFFFFF"/>
+                </a:solidFill>
+              </a:defRPr>
+            </a:pPr>
+            <a:r>
+              <a:t>Project Closure — Results &amp; Lessons Learned</a:t>
+            </a:r>
+          </a:p>
+        </p:txBody>
+      </p:sp>
+      <p:sp>
+        <p:nvSpPr>
+          <p:cNvPr id="3" name="TextBox 2"/>
+          <p:cNvSpPr txBox="1"/>
+          <p:nvPr/>
+        </p:nvSpPr>
+        <p:spPr>
+          <a:xfrm>
+            <a:off x="548640" y="1188720"/>
+            <a:ext cx="5303520" cy="2286000"/>
+          </a:xfrm>
+          <a:prstGeom prst="rect">
+            <a:avLst/>
+          </a:prstGeom>
+          <a:noFill/>
+        </p:spPr>
+        <p:txBody>
+          <a:bodyPr wrap="square">
+            <a:spAutoFit/>
+          </a:bodyPr>
+          <a:lstStyle/>
+          <a:p>
+            <a:pPr>
+              <a:defRPr sz="1600" b="1">
+                <a:solidFill>
+                  <a:srgbClr val="2E8B57"/>
+                </a:solidFill>
+              </a:defRPr>
+            </a:pPr>
+            <a:r>
+              <a:t>✓  Hits (What Went Right)</a:t>
+            </a:r>
+          </a:p>
+          <a:p>
+            <a:pPr>
+              <a:spcAft>
+                <a:spcPts val="400"/>
+              </a:spcAft>
+              <a:defRPr sz="1200">
+                <a:solidFill>
+                  <a:srgbClr val="222222"/>
+                </a:solidFill>
+              </a:defRPr>
+            </a:pPr>
+            <a:r>
+              <a:t>▸  Centralized cloud infrastructure deployed (4 VMs, 32 GB RAM)</a:t>
+            </a:r>
+          </a:p>
+          <a:p>
+            <a:pPr>
+              <a:spcAft>
+                <a:spcPts val="400"/>
+              </a:spcAft>
+              <a:defRPr sz="1200">
+                <a:solidFill>
+                  <a:srgbClr val="222222"/>
+                </a:solidFill>
+              </a:defRPr>
+            </a:pPr>
+            <a:r>
+              <a:t>▸  100% elimination of 53,208 duplicate records</a:t>
+            </a:r>
+          </a:p>
+          <a:p>
+            <a:pPr>
+              <a:spcAft>
+                <a:spcPts val="400"/>
+              </a:spcAft>
+              <a:defRPr sz="1200">
+                <a:solidFill>
+                  <a:srgbClr val="222222"/>
+                </a:solidFill>
+              </a:defRPr>
+            </a:pPr>
+            <a:r>
+              <a:t>▸  Sub-2-second query response across all branches</a:t>
+            </a:r>
+          </a:p>
+          <a:p>
+            <a:pPr>
+              <a:spcAft>
+                <a:spcPts val="400"/>
+              </a:spcAft>
+              <a:defRPr sz="1200">
+                <a:solidFill>
+                  <a:srgbClr val="222222"/>
+                </a:solidFill>
+              </a:defRPr>
+            </a:pPr>
+            <a:r>
+              <a:t>▸  Objective provider selection via weighted criteria (7.8/10)</a:t>
+            </a:r>
+          </a:p>
+          <a:p>
+            <a:pPr>
+              <a:spcAft>
+                <a:spcPts val="400"/>
+              </a:spcAft>
+              <a:defRPr sz="1200">
+                <a:solidFill>
+                  <a:srgbClr val="222222"/>
+                </a:solidFill>
+              </a:defRPr>
+            </a:pPr>
+            <a:r>
+              <a:t>▸  Change control kept July 31 go-live on track</a:t>
+            </a:r>
+          </a:p>
+        </p:txBody>
+      </p:sp>
+      <p:sp>
+        <p:nvSpPr>
+          <p:cNvPr id="4" name="TextBox 3"/>
+          <p:cNvSpPr txBox="1"/>
+          <p:nvPr/>
+        </p:nvSpPr>
+        <p:spPr>
+          <a:xfrm>
+            <a:off x="6400800" y="1188720"/>
+            <a:ext cx="5303520" cy="2286000"/>
+          </a:xfrm>
+          <a:prstGeom prst="rect">
+            <a:avLst/>
+          </a:prstGeom>
+          <a:noFill/>
+        </p:spPr>
+        <p:txBody>
+          <a:bodyPr wrap="square">
+            <a:spAutoFit/>
+          </a:bodyPr>
+          <a:lstStyle/>
+          <a:p>
+            <a:pPr>
+              <a:defRPr sz="1600" b="1">
+                <a:solidFill>
+                  <a:srgbClr val="B85042"/>
+                </a:solidFill>
+              </a:defRPr>
+            </a:pPr>
+            <a:r>
+              <a:t>✗  Failures (What Went Wrong)</a:t>
+            </a:r>
+          </a:p>
+          <a:p>
+            <a:pPr>
+              <a:spcAft>
+                <a:spcPts val="400"/>
+              </a:spcAft>
+              <a:defRPr sz="1200">
+                <a:solidFill>
+                  <a:srgbClr val="222222"/>
+                </a:solidFill>
+              </a:defRPr>
+            </a:pPr>
+            <a:r>
+              <a:t>▸  C1 delayed 2 days — no backup owner assigned</a:t>
+            </a:r>
+          </a:p>
+          <a:p>
+            <a:pPr>
+              <a:spcAft>
+                <a:spcPts val="400"/>
+              </a:spcAft>
+              <a:defRPr sz="1200">
+                <a:solidFill>
+                  <a:srgbClr val="222222"/>
+                </a:solidFill>
+              </a:defRPr>
+            </a:pPr>
+            <a:r>
+              <a:t>▸  3 procurement deliverables pending at Week 4</a:t>
+            </a:r>
+          </a:p>
+          <a:p>
+            <a:pPr>
+              <a:spcAft>
+                <a:spcPts val="400"/>
+              </a:spcAft>
+              <a:defRPr sz="1200">
+                <a:solidFill>
+                  <a:srgbClr val="222222"/>
+                </a:solidFill>
+              </a:defRPr>
+            </a:pPr>
+            <a:r>
+              <a:t>▸  C6 underestimated: record volume needed +3 days</a:t>
+            </a:r>
+          </a:p>
+          <a:p>
+            <a:pPr>
+              <a:spcAft>
+                <a:spcPts val="400"/>
+              </a:spcAft>
+              <a:defRPr sz="1200">
+                <a:solidFill>
+                  <a:srgbClr val="222222"/>
+                </a:solidFill>
+              </a:defRPr>
+            </a:pPr>
+            <a:r>
+              <a:t>▸  EVA formulas initially swapped (SV/CV corrected)</a:t>
+            </a:r>
+          </a:p>
+        </p:txBody>
+      </p:sp>
+      <p:sp>
+        <p:nvSpPr>
+          <p:cNvPr id="5" name="TextBox 4"/>
+          <p:cNvSpPr txBox="1"/>
+          <p:nvPr/>
+        </p:nvSpPr>
+        <p:spPr>
+          <a:xfrm>
+            <a:off x="548640" y="3657600"/>
+            <a:ext cx="10972800" cy="2743200"/>
+          </a:xfrm>
+          <a:prstGeom prst="rect">
+            <a:avLst/>
+          </a:prstGeom>
+          <a:noFill/>
+        </p:spPr>
+        <p:txBody>
+          <a:bodyPr wrap="square">
+            <a:spAutoFit/>
+          </a:bodyPr>
+          <a:lstStyle/>
+          <a:p>
+            <a:pPr>
+              <a:defRPr sz="1600" b="1">
+                <a:solidFill>
+                  <a:srgbClr val="028090"/>
+                </a:solidFill>
+              </a:defRPr>
+            </a:pPr>
+            <a:r>
+              <a:t>→  Improvements for Future Projects</a:t>
+            </a:r>
+          </a:p>
+          <a:p>
+            <a:pPr>
+              <a:spcAft>
+                <a:spcPts val="400"/>
+              </a:spcAft>
+              <a:defRPr sz="1300">
+                <a:solidFill>
+                  <a:srgbClr val="222222"/>
+                </a:solidFill>
+              </a:defRPr>
+            </a:pPr>
+            <a:r>
+              <a:t>▸  Assign backup owners for every critical-path activity</a:t>
+            </a:r>
+          </a:p>
+          <a:p>
+            <a:pPr>
+              <a:spcAft>
+                <a:spcPts val="400"/>
+              </a:spcAft>
+              <a:defRPr sz="1300">
+                <a:solidFill>
+                  <a:srgbClr val="222222"/>
+                </a:solidFill>
+              </a:defRPr>
+            </a:pPr>
+            <a:r>
+              <a:t>▸  Use per-record parametric estimation instead of flat durations for digitization</a:t>
+            </a:r>
+          </a:p>
+          <a:p>
+            <a:pPr>
+              <a:spcAft>
+                <a:spcPts val="400"/>
+              </a:spcAft>
+              <a:defRPr sz="1300">
+                <a:solidFill>
+                  <a:srgbClr val="222222"/>
+                </a:solidFill>
+              </a:defRPr>
+            </a:pPr>
+            <a:r>
+              <a:t>▸  Pre-qualify vendors and lock SLAs during Week 1</a:t>
+            </a:r>
+          </a:p>
+          <a:p>
+            <a:pPr>
+              <a:spcAft>
+                <a:spcPts val="400"/>
+              </a:spcAft>
+              <a:defRPr sz="1300">
+                <a:solidFill>
+                  <a:srgbClr val="222222"/>
+                </a:solidFill>
+              </a:defRPr>
+            </a:pPr>
+            <a:r>
+              <a:t>▸  Standardize EVA templates to prevent formula confusion</a:t>
+            </a:r>
+          </a:p>
+          <a:p>
+            <a:pPr>
+              <a:spcAft>
+                <a:spcPts val="400"/>
+              </a:spcAft>
+              <a:defRPr sz="1300">
+                <a:solidFill>
+                  <a:srgbClr val="222222"/>
+                </a:solidFill>
+              </a:defRPr>
+            </a:pPr>
+            <a:r>
+              <a:t>▸  Keep daily stand-up alignment meetings (introduced during rework)</a:t>
+            </a:r>
+          </a:p>
+        </p:txBody>
+      </p:sp>
+    </p:spTree>
+  </p:cSld>
+  <p:clrMapOvr>
+    <a:masterClrMapping/>
+  </p:clrMapOvr>
+</p:sld>
+</file>
+
+<file path=ppt/slides/slide11.xml><?xml version="1.0" encoding="utf-8"?>
+<p:sld xmlns:a="http://schemas.openxmlformats.org/drawingml/2006/main" xmlns:p="http://schemas.openxmlformats.org/presentationml/2006/main" xmlns:r="http://schemas.openxmlformats.org/officeDocument/2006/relationships">
+  <p:cSld>
+    <p:bg>
+      <p:bgPr>
+        <a:solidFill>
+          <a:srgbClr val="2F3C7E"/>
+        </a:solidFill>
+        <a:effectLst/>
+      </p:bgPr>
+    </p:bg>
+    <p:spTree>
+      <p:nvGrpSpPr>
+        <p:cNvPr id="1" name=""/>
+        <p:cNvGrpSpPr/>
+        <p:nvPr/>
+      </p:nvGrpSpPr>
+      <p:grpSpPr/>
+      <p:sp>
+        <p:nvSpPr>
+          <p:cNvPr id="2" name="TextBox 1"/>
+          <p:cNvSpPr txBox="1"/>
+          <p:nvPr/>
+        </p:nvSpPr>
+        <p:spPr>
+          <a:xfrm>
+            <a:off x="914400" y="1371600"/>
+            <a:ext cx="10058400" cy="4114800"/>
+          </a:xfrm>
+          <a:prstGeom prst="rect">
+            <a:avLst/>
+          </a:prstGeom>
+          <a:noFill/>
+        </p:spPr>
+        <p:txBody>
+          <a:bodyPr wrap="square">
+            <a:spAutoFit/>
+          </a:bodyPr>
+          <a:lstStyle/>
+          <a:p>
+            <a:pPr algn="ctr">
+              <a:defRPr sz="4000" b="1">
+                <a:solidFill>
+                  <a:srgbClr val="FFFFFF"/>
+                </a:solidFill>
+              </a:defRPr>
+            </a:pPr>
+            <a:r>
+              <a:t>Conclusion</a:t>
+            </a:r>
+          </a:p>
+          <a:p>
+            <a:pPr algn="ctr">
+              <a:spcBef>
+                <a:spcPts val="1600"/>
+              </a:spcBef>
+              <a:defRPr sz="1800">
+                <a:solidFill>
+                  <a:srgbClr val="CCCCCC"/>
+                </a:solidFill>
+              </a:defRPr>
+            </a:pPr>
+            <a:r>
+              <a:t>The project achieved its strategic objective: 3 branches consolidated on a single cloud platform</a:t>
+            </a:r>
+          </a:p>
+          <a:p>
+            <a:pPr algn="ctr">
+              <a:spcBef>
+                <a:spcPts val="1600"/>
+              </a:spcBef>
+              <a:defRPr sz="1800">
+                <a:solidFill>
+                  <a:srgbClr val="CCCCCC"/>
+                </a:solidFill>
+              </a:defRPr>
+            </a:pPr>
+            <a:r>
+              <a:t>53,208 duplicate records eliminated → 0% redundancy</a:t>
+            </a:r>
+          </a:p>
+          <a:p>
+            <a:pPr algn="ctr">
+              <a:spcBef>
+                <a:spcPts val="1600"/>
+              </a:spcBef>
+              <a:defRPr sz="1800">
+                <a:solidFill>
+                  <a:srgbClr val="CCCCCC"/>
+                </a:solidFill>
+              </a:defRPr>
+            </a:pPr>
+            <a:r>
+              <a:t>EVA at Week 4: SPI 0.93, CPI 0.957 — corrective action via crashing + contingency reserve</a:t>
+            </a:r>
+          </a:p>
+          <a:p>
+            <a:pPr algn="ctr">
+              <a:spcBef>
+                <a:spcPts val="1600"/>
+              </a:spcBef>
+              <a:defRPr sz="1800">
+                <a:solidFill>
+                  <a:srgbClr val="CCCCCC"/>
+                </a:solidFill>
+              </a:defRPr>
+            </a:pPr>
+            <a:r>
+              <a:t>Delivered on time (July 31, 2026) and within adjusted budget</a:t>
+            </a:r>
+          </a:p>
+          <a:p>
+            <a:pPr algn="ctr">
+              <a:spcBef>
+                <a:spcPts val="1600"/>
+              </a:spcBef>
+              <a:defRPr sz="1800">
+                <a:solidFill>
+                  <a:srgbClr val="CCCCCC"/>
+                </a:solidFill>
+              </a:defRPr>
+            </a:pPr>
+            <a:r>
+              <a:t>Structured change control absorbed 5 disruption events without derailing the critical path</a:t>
+            </a:r>
+          </a:p>
+          <a:p>
+            <a:pPr>
+              <a:spcBef>
+                <a:spcPts val="3000"/>
+              </a:spcBef>
+            </a:pPr>
+          </a:p>
+          <a:p>
+            <a:pPr algn="ctr">
+              <a:defRPr sz="2400" b="1">
+                <a:solidFill>
+                  <a:srgbClr val="E7A33E"/>
+                </a:solidFill>
+              </a:defRPr>
+            </a:pPr>
+            <a:r>
+              <a:t>Thank you — Questions?</a:t>
             </a:r>
           </a:p>
         </p:txBody>
@@ -4623,6 +5165,264 @@
 </file>
 
 <file path=ppt/slides/slide7.xml><?xml version="1.0" encoding="utf-8"?>
+<p:sld xmlns:a="http://schemas.openxmlformats.org/drawingml/2006/main" xmlns:p="http://schemas.openxmlformats.org/presentationml/2006/main" xmlns:r="http://schemas.openxmlformats.org/officeDocument/2006/relationships">
+  <p:cSld>
+    <p:spTree>
+      <p:nvGrpSpPr>
+        <p:cNvPr id="1" name=""/>
+        <p:cNvGrpSpPr/>
+        <p:nvPr/>
+      </p:nvGrpSpPr>
+      <p:grpSpPr/>
+      <p:sp>
+        <p:nvSpPr>
+          <p:cNvPr id="2" name="Rectangle 1"/>
+          <p:cNvSpPr/>
+          <p:nvPr/>
+        </p:nvSpPr>
+        <p:spPr>
+          <a:xfrm>
+            <a:off x="0" y="0"/>
+            <a:ext cx="12191695" cy="1005840"/>
+          </a:xfrm>
+          <a:prstGeom prst="rect">
+            <a:avLst/>
+          </a:prstGeom>
+          <a:solidFill>
+            <a:srgbClr val="2F3C7E"/>
+          </a:solidFill>
+          <a:ln>
+            <a:noFill/>
+          </a:ln>
+        </p:spPr>
+        <p:style>
+          <a:lnRef idx="1">
+            <a:schemeClr val="accent1"/>
+          </a:lnRef>
+          <a:fillRef idx="3">
+            <a:schemeClr val="accent1"/>
+          </a:fillRef>
+          <a:effectRef idx="2">
+            <a:schemeClr val="accent1"/>
+          </a:effectRef>
+          <a:fontRef idx="minor">
+            <a:schemeClr val="lt1"/>
+          </a:fontRef>
+        </p:style>
+        <p:txBody>
+          <a:bodyPr rtlCol="0" anchor="ctr" wrap="square" lIns="548640" tIns="137160"/>
+          <a:lstStyle/>
+          <a:p>
+            <a:pPr algn="l">
+              <a:defRPr sz="3200" b="1">
+                <a:solidFill>
+                  <a:srgbClr val="FFFFFF"/>
+                </a:solidFill>
+              </a:defRPr>
+            </a:pPr>
+            <a:r>
+              <a:t>EVM — S-Curve: Cumulative Cost Performance</a:t>
+            </a:r>
+          </a:p>
+        </p:txBody>
+      </p:sp>
+      <p:sp>
+        <p:nvSpPr>
+          <p:cNvPr id="3" name="TextBox 2"/>
+          <p:cNvSpPr txBox="1"/>
+          <p:nvPr/>
+        </p:nvSpPr>
+        <p:spPr>
+          <a:xfrm>
+            <a:off x="548640" y="1188720"/>
+            <a:ext cx="10972800" cy="457200"/>
+          </a:xfrm>
+          <a:prstGeom prst="rect">
+            <a:avLst/>
+          </a:prstGeom>
+          <a:noFill/>
+        </p:spPr>
+        <p:txBody>
+          <a:bodyPr wrap="none">
+            <a:spAutoFit/>
+          </a:bodyPr>
+          <a:lstStyle/>
+          <a:p>
+            <a:pPr>
+              <a:defRPr sz="1600" i="1">
+                <a:solidFill>
+                  <a:srgbClr val="666666"/>
+                </a:solidFill>
+              </a:defRPr>
+            </a:pPr>
+            <a:r>
+              <a:t>PV vs EV vs AC over the 8-week project timeline</a:t>
+            </a:r>
+          </a:p>
+        </p:txBody>
+      </p:sp>
+      <p:pic>
+        <p:nvPicPr>
+          <p:cNvPr id="4" name="Picture 3" descr="s_curve.png"/>
+          <p:cNvPicPr>
+            <a:picLocks noChangeAspect="1"/>
+          </p:cNvPicPr>
+          <p:nvPr/>
+        </p:nvPicPr>
+        <p:blipFill>
+          <a:blip r:embed="rId2"/>
+          <a:stretch>
+            <a:fillRect/>
+          </a:stretch>
+        </p:blipFill>
+        <p:spPr>
+          <a:xfrm>
+            <a:off x="457200" y="1371600"/>
+            <a:ext cx="11247120" cy="5029200"/>
+          </a:xfrm>
+          <a:prstGeom prst="rect">
+            <a:avLst/>
+          </a:prstGeom>
+        </p:spPr>
+      </p:pic>
+    </p:spTree>
+  </p:cSld>
+  <p:clrMapOvr>
+    <a:masterClrMapping/>
+  </p:clrMapOvr>
+</p:sld>
+</file>
+
+<file path=ppt/slides/slide8.xml><?xml version="1.0" encoding="utf-8"?>
+<p:sld xmlns:a="http://schemas.openxmlformats.org/drawingml/2006/main" xmlns:p="http://schemas.openxmlformats.org/presentationml/2006/main" xmlns:r="http://schemas.openxmlformats.org/officeDocument/2006/relationships">
+  <p:cSld>
+    <p:spTree>
+      <p:nvGrpSpPr>
+        <p:cNvPr id="1" name=""/>
+        <p:cNvGrpSpPr/>
+        <p:nvPr/>
+      </p:nvGrpSpPr>
+      <p:grpSpPr/>
+      <p:sp>
+        <p:nvSpPr>
+          <p:cNvPr id="2" name="Rectangle 1"/>
+          <p:cNvSpPr/>
+          <p:nvPr/>
+        </p:nvSpPr>
+        <p:spPr>
+          <a:xfrm>
+            <a:off x="0" y="0"/>
+            <a:ext cx="12191695" cy="1005840"/>
+          </a:xfrm>
+          <a:prstGeom prst="rect">
+            <a:avLst/>
+          </a:prstGeom>
+          <a:solidFill>
+            <a:srgbClr val="2F3C7E"/>
+          </a:solidFill>
+          <a:ln>
+            <a:noFill/>
+          </a:ln>
+        </p:spPr>
+        <p:style>
+          <a:lnRef idx="1">
+            <a:schemeClr val="accent1"/>
+          </a:lnRef>
+          <a:fillRef idx="3">
+            <a:schemeClr val="accent1"/>
+          </a:fillRef>
+          <a:effectRef idx="2">
+            <a:schemeClr val="accent1"/>
+          </a:effectRef>
+          <a:fontRef idx="minor">
+            <a:schemeClr val="lt1"/>
+          </a:fontRef>
+        </p:style>
+        <p:txBody>
+          <a:bodyPr rtlCol="0" anchor="ctr" wrap="square" lIns="548640" tIns="137160"/>
+          <a:lstStyle/>
+          <a:p>
+            <a:pPr algn="l">
+              <a:defRPr sz="3200" b="1">
+                <a:solidFill>
+                  <a:srgbClr val="FFFFFF"/>
+                </a:solidFill>
+              </a:defRPr>
+            </a:pPr>
+            <a:r>
+              <a:t>Cost by Activity: Budget vs Actual at Week 4</a:t>
+            </a:r>
+          </a:p>
+        </p:txBody>
+      </p:sp>
+      <p:sp>
+        <p:nvSpPr>
+          <p:cNvPr id="3" name="TextBox 2"/>
+          <p:cNvSpPr txBox="1"/>
+          <p:nvPr/>
+        </p:nvSpPr>
+        <p:spPr>
+          <a:xfrm>
+            <a:off x="548640" y="1188720"/>
+            <a:ext cx="10972800" cy="457200"/>
+          </a:xfrm>
+          <a:prstGeom prst="rect">
+            <a:avLst/>
+          </a:prstGeom>
+          <a:noFill/>
+        </p:spPr>
+        <p:txBody>
+          <a:bodyPr wrap="none">
+            <a:spAutoFit/>
+          </a:bodyPr>
+          <a:lstStyle/>
+          <a:p>
+            <a:pPr>
+              <a:defRPr sz="1600" i="1">
+                <a:solidFill>
+                  <a:srgbClr val="666666"/>
+                </a:solidFill>
+              </a:defRPr>
+            </a:pPr>
+            <a:r>
+              <a:t>C4 dominates the budget (55K) — equipment + cloud provider</a:t>
+            </a:r>
+          </a:p>
+        </p:txBody>
+      </p:sp>
+      <p:pic>
+        <p:nvPicPr>
+          <p:cNvPr id="4" name="Picture 3" descr="cost_by_activity.png"/>
+          <p:cNvPicPr>
+            <a:picLocks noChangeAspect="1"/>
+          </p:cNvPicPr>
+          <p:nvPr/>
+        </p:nvPicPr>
+        <p:blipFill>
+          <a:blip r:embed="rId2"/>
+          <a:stretch>
+            <a:fillRect/>
+          </a:stretch>
+        </p:blipFill>
+        <p:spPr>
+          <a:xfrm>
+            <a:off x="457200" y="1371600"/>
+            <a:ext cx="11247120" cy="5029200"/>
+          </a:xfrm>
+          <a:prstGeom prst="rect">
+            <a:avLst/>
+          </a:prstGeom>
+        </p:spPr>
+      </p:pic>
+    </p:spTree>
+  </p:cSld>
+  <p:clrMapOvr>
+    <a:masterClrMapping/>
+  </p:clrMapOvr>
+</p:sld>
+</file>
+
+<file path=ppt/slides/slide9.xml><?xml version="1.0" encoding="utf-8"?>
 <p:sld xmlns:a="http://schemas.openxmlformats.org/drawingml/2006/main" xmlns:p="http://schemas.openxmlformats.org/presentationml/2006/main" xmlns:r="http://schemas.openxmlformats.org/officeDocument/2006/relationships">
   <p:cSld>
     <p:spTree>
@@ -5418,546 +6218,6 @@
 </p:sld>
 </file>
 
-<file path=ppt/slides/slide8.xml><?xml version="1.0" encoding="utf-8"?>
-<p:sld xmlns:a="http://schemas.openxmlformats.org/drawingml/2006/main" xmlns:p="http://schemas.openxmlformats.org/presentationml/2006/main" xmlns:r="http://schemas.openxmlformats.org/officeDocument/2006/relationships">
-  <p:cSld>
-    <p:spTree>
-      <p:nvGrpSpPr>
-        <p:cNvPr id="1" name=""/>
-        <p:cNvGrpSpPr/>
-        <p:nvPr/>
-      </p:nvGrpSpPr>
-      <p:grpSpPr/>
-      <p:sp>
-        <p:nvSpPr>
-          <p:cNvPr id="2" name="Rectangle 1"/>
-          <p:cNvSpPr/>
-          <p:nvPr/>
-        </p:nvSpPr>
-        <p:spPr>
-          <a:xfrm>
-            <a:off x="0" y="0"/>
-            <a:ext cx="12191695" cy="1005840"/>
-          </a:xfrm>
-          <a:prstGeom prst="rect">
-            <a:avLst/>
-          </a:prstGeom>
-          <a:solidFill>
-            <a:srgbClr val="2F3C7E"/>
-          </a:solidFill>
-          <a:ln>
-            <a:noFill/>
-          </a:ln>
-        </p:spPr>
-        <p:style>
-          <a:lnRef idx="1">
-            <a:schemeClr val="accent1"/>
-          </a:lnRef>
-          <a:fillRef idx="3">
-            <a:schemeClr val="accent1"/>
-          </a:fillRef>
-          <a:effectRef idx="2">
-            <a:schemeClr val="accent1"/>
-          </a:effectRef>
-          <a:fontRef idx="minor">
-            <a:schemeClr val="lt1"/>
-          </a:fontRef>
-        </p:style>
-        <p:txBody>
-          <a:bodyPr rtlCol="0" anchor="ctr" wrap="square" lIns="548640" tIns="137160"/>
-          <a:lstStyle/>
-          <a:p>
-            <a:pPr algn="l">
-              <a:defRPr sz="3200" b="1">
-                <a:solidFill>
-                  <a:srgbClr val="FFFFFF"/>
-                </a:solidFill>
-              </a:defRPr>
-            </a:pPr>
-            <a:r>
-              <a:t>Project Closure — Results &amp; Lessons Learned</a:t>
-            </a:r>
-          </a:p>
-        </p:txBody>
-      </p:sp>
-      <p:sp>
-        <p:nvSpPr>
-          <p:cNvPr id="3" name="TextBox 2"/>
-          <p:cNvSpPr txBox="1"/>
-          <p:nvPr/>
-        </p:nvSpPr>
-        <p:spPr>
-          <a:xfrm>
-            <a:off x="548640" y="1188720"/>
-            <a:ext cx="5303520" cy="2286000"/>
-          </a:xfrm>
-          <a:prstGeom prst="rect">
-            <a:avLst/>
-          </a:prstGeom>
-          <a:noFill/>
-        </p:spPr>
-        <p:txBody>
-          <a:bodyPr wrap="square">
-            <a:spAutoFit/>
-          </a:bodyPr>
-          <a:lstStyle/>
-          <a:p>
-            <a:pPr>
-              <a:defRPr sz="1600" b="1">
-                <a:solidFill>
-                  <a:srgbClr val="2E8B57"/>
-                </a:solidFill>
-              </a:defRPr>
-            </a:pPr>
-            <a:r>
-              <a:t>✓  Hits (What Went Right)</a:t>
-            </a:r>
-          </a:p>
-          <a:p>
-            <a:pPr>
-              <a:spcAft>
-                <a:spcPts val="400"/>
-              </a:spcAft>
-              <a:defRPr sz="1200">
-                <a:solidFill>
-                  <a:srgbClr val="222222"/>
-                </a:solidFill>
-              </a:defRPr>
-            </a:pPr>
-            <a:r>
-              <a:t>▸  Centralized cloud infrastructure deployed (4 VMs, 32 GB RAM)</a:t>
-            </a:r>
-          </a:p>
-          <a:p>
-            <a:pPr>
-              <a:spcAft>
-                <a:spcPts val="400"/>
-              </a:spcAft>
-              <a:defRPr sz="1200">
-                <a:solidFill>
-                  <a:srgbClr val="222222"/>
-                </a:solidFill>
-              </a:defRPr>
-            </a:pPr>
-            <a:r>
-              <a:t>▸  100% elimination of 53,208 duplicate records</a:t>
-            </a:r>
-          </a:p>
-          <a:p>
-            <a:pPr>
-              <a:spcAft>
-                <a:spcPts val="400"/>
-              </a:spcAft>
-              <a:defRPr sz="1200">
-                <a:solidFill>
-                  <a:srgbClr val="222222"/>
-                </a:solidFill>
-              </a:defRPr>
-            </a:pPr>
-            <a:r>
-              <a:t>▸  Sub-2-second query response across all branches</a:t>
-            </a:r>
-          </a:p>
-          <a:p>
-            <a:pPr>
-              <a:spcAft>
-                <a:spcPts val="400"/>
-              </a:spcAft>
-              <a:defRPr sz="1200">
-                <a:solidFill>
-                  <a:srgbClr val="222222"/>
-                </a:solidFill>
-              </a:defRPr>
-            </a:pPr>
-            <a:r>
-              <a:t>▸  Objective provider selection via weighted criteria (7.8/10)</a:t>
-            </a:r>
-          </a:p>
-          <a:p>
-            <a:pPr>
-              <a:spcAft>
-                <a:spcPts val="400"/>
-              </a:spcAft>
-              <a:defRPr sz="1200">
-                <a:solidFill>
-                  <a:srgbClr val="222222"/>
-                </a:solidFill>
-              </a:defRPr>
-            </a:pPr>
-            <a:r>
-              <a:t>▸  Change control kept July 31 go-live on track</a:t>
-            </a:r>
-          </a:p>
-        </p:txBody>
-      </p:sp>
-      <p:sp>
-        <p:nvSpPr>
-          <p:cNvPr id="4" name="TextBox 3"/>
-          <p:cNvSpPr txBox="1"/>
-          <p:nvPr/>
-        </p:nvSpPr>
-        <p:spPr>
-          <a:xfrm>
-            <a:off x="6400800" y="1188720"/>
-            <a:ext cx="5303520" cy="2286000"/>
-          </a:xfrm>
-          <a:prstGeom prst="rect">
-            <a:avLst/>
-          </a:prstGeom>
-          <a:noFill/>
-        </p:spPr>
-        <p:txBody>
-          <a:bodyPr wrap="square">
-            <a:spAutoFit/>
-          </a:bodyPr>
-          <a:lstStyle/>
-          <a:p>
-            <a:pPr>
-              <a:defRPr sz="1600" b="1">
-                <a:solidFill>
-                  <a:srgbClr val="B85042"/>
-                </a:solidFill>
-              </a:defRPr>
-            </a:pPr>
-            <a:r>
-              <a:t>✗  Failures (What Went Wrong)</a:t>
-            </a:r>
-          </a:p>
-          <a:p>
-            <a:pPr>
-              <a:spcAft>
-                <a:spcPts val="400"/>
-              </a:spcAft>
-              <a:defRPr sz="1200">
-                <a:solidFill>
-                  <a:srgbClr val="222222"/>
-                </a:solidFill>
-              </a:defRPr>
-            </a:pPr>
-            <a:r>
-              <a:t>▸  C1 delayed 2 days — no backup owner assigned</a:t>
-            </a:r>
-          </a:p>
-          <a:p>
-            <a:pPr>
-              <a:spcAft>
-                <a:spcPts val="400"/>
-              </a:spcAft>
-              <a:defRPr sz="1200">
-                <a:solidFill>
-                  <a:srgbClr val="222222"/>
-                </a:solidFill>
-              </a:defRPr>
-            </a:pPr>
-            <a:r>
-              <a:t>▸  3 procurement deliverables pending at Week 4</a:t>
-            </a:r>
-          </a:p>
-          <a:p>
-            <a:pPr>
-              <a:spcAft>
-                <a:spcPts val="400"/>
-              </a:spcAft>
-              <a:defRPr sz="1200">
-                <a:solidFill>
-                  <a:srgbClr val="222222"/>
-                </a:solidFill>
-              </a:defRPr>
-            </a:pPr>
-            <a:r>
-              <a:t>▸  C6 underestimated: record volume needed +3 days</a:t>
-            </a:r>
-          </a:p>
-          <a:p>
-            <a:pPr>
-              <a:spcAft>
-                <a:spcPts val="400"/>
-              </a:spcAft>
-              <a:defRPr sz="1200">
-                <a:solidFill>
-                  <a:srgbClr val="222222"/>
-                </a:solidFill>
-              </a:defRPr>
-            </a:pPr>
-            <a:r>
-              <a:t>▸  EVA formulas initially swapped (SV/CV corrected)</a:t>
-            </a:r>
-          </a:p>
-        </p:txBody>
-      </p:sp>
-      <p:sp>
-        <p:nvSpPr>
-          <p:cNvPr id="5" name="TextBox 4"/>
-          <p:cNvSpPr txBox="1"/>
-          <p:nvPr/>
-        </p:nvSpPr>
-        <p:spPr>
-          <a:xfrm>
-            <a:off x="548640" y="3657600"/>
-            <a:ext cx="10972800" cy="2743200"/>
-          </a:xfrm>
-          <a:prstGeom prst="rect">
-            <a:avLst/>
-          </a:prstGeom>
-          <a:noFill/>
-        </p:spPr>
-        <p:txBody>
-          <a:bodyPr wrap="square">
-            <a:spAutoFit/>
-          </a:bodyPr>
-          <a:lstStyle/>
-          <a:p>
-            <a:pPr>
-              <a:defRPr sz="1600" b="1">
-                <a:solidFill>
-                  <a:srgbClr val="028090"/>
-                </a:solidFill>
-              </a:defRPr>
-            </a:pPr>
-            <a:r>
-              <a:t>→  Improvements for Future Projects</a:t>
-            </a:r>
-          </a:p>
-          <a:p>
-            <a:pPr>
-              <a:spcAft>
-                <a:spcPts val="400"/>
-              </a:spcAft>
-              <a:defRPr sz="1300">
-                <a:solidFill>
-                  <a:srgbClr val="222222"/>
-                </a:solidFill>
-              </a:defRPr>
-            </a:pPr>
-            <a:r>
-              <a:t>▸  Assign backup owners for every critical-path activity</a:t>
-            </a:r>
-          </a:p>
-          <a:p>
-            <a:pPr>
-              <a:spcAft>
-                <a:spcPts val="400"/>
-              </a:spcAft>
-              <a:defRPr sz="1300">
-                <a:solidFill>
-                  <a:srgbClr val="222222"/>
-                </a:solidFill>
-              </a:defRPr>
-            </a:pPr>
-            <a:r>
-              <a:t>▸  Use per-record parametric estimation instead of flat durations for digitization</a:t>
-            </a:r>
-          </a:p>
-          <a:p>
-            <a:pPr>
-              <a:spcAft>
-                <a:spcPts val="400"/>
-              </a:spcAft>
-              <a:defRPr sz="1300">
-                <a:solidFill>
-                  <a:srgbClr val="222222"/>
-                </a:solidFill>
-              </a:defRPr>
-            </a:pPr>
-            <a:r>
-              <a:t>▸  Pre-qualify vendors and lock SLAs during Week 1</a:t>
-            </a:r>
-          </a:p>
-          <a:p>
-            <a:pPr>
-              <a:spcAft>
-                <a:spcPts val="400"/>
-              </a:spcAft>
-              <a:defRPr sz="1300">
-                <a:solidFill>
-                  <a:srgbClr val="222222"/>
-                </a:solidFill>
-              </a:defRPr>
-            </a:pPr>
-            <a:r>
-              <a:t>▸  Standardize EVA templates to prevent formula confusion</a:t>
-            </a:r>
-          </a:p>
-          <a:p>
-            <a:pPr>
-              <a:spcAft>
-                <a:spcPts val="400"/>
-              </a:spcAft>
-              <a:defRPr sz="1300">
-                <a:solidFill>
-                  <a:srgbClr val="222222"/>
-                </a:solidFill>
-              </a:defRPr>
-            </a:pPr>
-            <a:r>
-              <a:t>▸  Keep daily stand-up alignment meetings (introduced during rework)</a:t>
-            </a:r>
-          </a:p>
-        </p:txBody>
-      </p:sp>
-    </p:spTree>
-  </p:cSld>
-  <p:clrMapOvr>
-    <a:masterClrMapping/>
-  </p:clrMapOvr>
-</p:sld>
-</file>
-
-<file path=ppt/slides/slide9.xml><?xml version="1.0" encoding="utf-8"?>
-<p:sld xmlns:a="http://schemas.openxmlformats.org/drawingml/2006/main" xmlns:p="http://schemas.openxmlformats.org/presentationml/2006/main" xmlns:r="http://schemas.openxmlformats.org/officeDocument/2006/relationships">
-  <p:cSld>
-    <p:bg>
-      <p:bgPr>
-        <a:solidFill>
-          <a:srgbClr val="2F3C7E"/>
-        </a:solidFill>
-        <a:effectLst/>
-      </p:bgPr>
-    </p:bg>
-    <p:spTree>
-      <p:nvGrpSpPr>
-        <p:cNvPr id="1" name=""/>
-        <p:cNvGrpSpPr/>
-        <p:nvPr/>
-      </p:nvGrpSpPr>
-      <p:grpSpPr/>
-      <p:sp>
-        <p:nvSpPr>
-          <p:cNvPr id="2" name="TextBox 1"/>
-          <p:cNvSpPr txBox="1"/>
-          <p:nvPr/>
-        </p:nvSpPr>
-        <p:spPr>
-          <a:xfrm>
-            <a:off x="914400" y="1371600"/>
-            <a:ext cx="10058400" cy="4114800"/>
-          </a:xfrm>
-          <a:prstGeom prst="rect">
-            <a:avLst/>
-          </a:prstGeom>
-          <a:noFill/>
-        </p:spPr>
-        <p:txBody>
-          <a:bodyPr wrap="square">
-            <a:spAutoFit/>
-          </a:bodyPr>
-          <a:lstStyle/>
-          <a:p>
-            <a:pPr algn="ctr">
-              <a:defRPr sz="4000" b="1">
-                <a:solidFill>
-                  <a:srgbClr val="FFFFFF"/>
-                </a:solidFill>
-              </a:defRPr>
-            </a:pPr>
-            <a:r>
-              <a:t>Conclusion</a:t>
-            </a:r>
-          </a:p>
-          <a:p>
-            <a:pPr algn="ctr">
-              <a:spcBef>
-                <a:spcPts val="1600"/>
-              </a:spcBef>
-              <a:defRPr sz="1800">
-                <a:solidFill>
-                  <a:srgbClr val="CCCCCC"/>
-                </a:solidFill>
-              </a:defRPr>
-            </a:pPr>
-            <a:r>
-              <a:t>The project achieved its strategic objective: 3 branches consolidated on a single cloud platform</a:t>
-            </a:r>
-          </a:p>
-          <a:p>
-            <a:pPr algn="ctr">
-              <a:spcBef>
-                <a:spcPts val="1600"/>
-              </a:spcBef>
-              <a:defRPr sz="1800">
-                <a:solidFill>
-                  <a:srgbClr val="CCCCCC"/>
-                </a:solidFill>
-              </a:defRPr>
-            </a:pPr>
-            <a:r>
-              <a:t>53,208 duplicate records eliminated → 0% redundancy</a:t>
-            </a:r>
-          </a:p>
-          <a:p>
-            <a:pPr algn="ctr">
-              <a:spcBef>
-                <a:spcPts val="1600"/>
-              </a:spcBef>
-              <a:defRPr sz="1800">
-                <a:solidFill>
-                  <a:srgbClr val="CCCCCC"/>
-                </a:solidFill>
-              </a:defRPr>
-            </a:pPr>
-            <a:r>
-              <a:t>EVA at Week 4: SPI 0.93, CPI 0.957 — corrective action via crashing + contingency reserve</a:t>
-            </a:r>
-          </a:p>
-          <a:p>
-            <a:pPr algn="ctr">
-              <a:spcBef>
-                <a:spcPts val="1600"/>
-              </a:spcBef>
-              <a:defRPr sz="1800">
-                <a:solidFill>
-                  <a:srgbClr val="CCCCCC"/>
-                </a:solidFill>
-              </a:defRPr>
-            </a:pPr>
-            <a:r>
-              <a:t>Delivered on time (July 31, 2026) and within adjusted budget</a:t>
-            </a:r>
-          </a:p>
-          <a:p>
-            <a:pPr algn="ctr">
-              <a:spcBef>
-                <a:spcPts val="1600"/>
-              </a:spcBef>
-              <a:defRPr sz="1800">
-                <a:solidFill>
-                  <a:srgbClr val="CCCCCC"/>
-                </a:solidFill>
-              </a:defRPr>
-            </a:pPr>
-            <a:r>
-              <a:t>Structured change control absorbed 5 disruption events without derailing the critical path</a:t>
-            </a:r>
-          </a:p>
-          <a:p>
-            <a:pPr>
-              <a:spcBef>
-                <a:spcPts val="3000"/>
-              </a:spcBef>
-            </a:pPr>
-          </a:p>
-          <a:p>
-            <a:pPr algn="ctr">
-              <a:defRPr sz="2400" b="1">
-                <a:solidFill>
-                  <a:srgbClr val="E7A33E"/>
-                </a:solidFill>
-              </a:defRPr>
-            </a:pPr>
-            <a:r>
-              <a:t>Thank you — Questions?</a:t>
-            </a:r>
-          </a:p>
-        </p:txBody>
-      </p:sp>
-    </p:spTree>
-  </p:cSld>
-  <p:clrMapOvr>
-    <a:masterClrMapping/>
-  </p:clrMapOvr>
-</p:sld>
-</file>
-
 <file path=ppt/theme/theme1.xml><?xml version="1.0" encoding="utf-8"?>
 <a:theme xmlns:a="http://schemas.openxmlformats.org/drawingml/2006/main" name="Office Theme">
   <a:themeElements>

</xml_diff>